<commit_message>
Numbers class rename to ArrayDequeHelper
</commit_message>
<xml_diff>
--- a/doc/arraydeque.pptx
+++ b/doc/arraydeque.pptx
@@ -10,6 +10,8 @@
     <p:sldId id="257" r:id="rId4"/>
     <p:sldId id="259" r:id="rId5"/>
     <p:sldId id="260" r:id="rId6"/>
+    <p:sldId id="261" r:id="rId7"/>
+    <p:sldId id="262" r:id="rId8"/>
   </p:sldIdLst>
   <p:sldSz cx="12192000" cy="6858000"/>
   <p:notesSz cx="6858000" cy="9144000"/>
@@ -838,7 +840,7 @@
           <a:p>
             <a:fld id="{F7EB0DB5-D797-4282-B608-3C30D79BDA58}" type="datetimeFigureOut">
               <a:rPr lang="hu-HU" smtClean="0"/>
-              <a:t>2026. 05. 06.</a:t>
+              <a:t>2026. 05. 09.</a:t>
             </a:fld>
             <a:endParaRPr lang="hu-HU"/>
           </a:p>
@@ -1089,7 +1091,7 @@
           <a:p>
             <a:fld id="{F7EB0DB5-D797-4282-B608-3C30D79BDA58}" type="datetimeFigureOut">
               <a:rPr lang="hu-HU" smtClean="0"/>
-              <a:t>2026. 05. 06.</a:t>
+              <a:t>2026. 05. 09.</a:t>
             </a:fld>
             <a:endParaRPr lang="hu-HU"/>
           </a:p>
@@ -1403,7 +1405,7 @@
           <a:p>
             <a:fld id="{F7EB0DB5-D797-4282-B608-3C30D79BDA58}" type="datetimeFigureOut">
               <a:rPr lang="hu-HU" smtClean="0"/>
-              <a:t>2026. 05. 06.</a:t>
+              <a:t>2026. 05. 09.</a:t>
             </a:fld>
             <a:endParaRPr lang="hu-HU"/>
           </a:p>
@@ -1744,7 +1746,7 @@
           <a:p>
             <a:fld id="{F7EB0DB5-D797-4282-B608-3C30D79BDA58}" type="datetimeFigureOut">
               <a:rPr lang="hu-HU" smtClean="0"/>
-              <a:t>2026. 05. 06.</a:t>
+              <a:t>2026. 05. 09.</a:t>
             </a:fld>
             <a:endParaRPr lang="hu-HU"/>
           </a:p>
@@ -2058,7 +2060,7 @@
           <a:p>
             <a:fld id="{F7EB0DB5-D797-4282-B608-3C30D79BDA58}" type="datetimeFigureOut">
               <a:rPr lang="hu-HU" smtClean="0"/>
-              <a:t>2026. 05. 06.</a:t>
+              <a:t>2026. 05. 09.</a:t>
             </a:fld>
             <a:endParaRPr lang="hu-HU"/>
           </a:p>
@@ -2451,7 +2453,7 @@
           <a:p>
             <a:fld id="{F7EB0DB5-D797-4282-B608-3C30D79BDA58}" type="datetimeFigureOut">
               <a:rPr lang="hu-HU" smtClean="0"/>
-              <a:t>2026. 05. 06.</a:t>
+              <a:t>2026. 05. 09.</a:t>
             </a:fld>
             <a:endParaRPr lang="hu-HU"/>
           </a:p>
@@ -2621,7 +2623,7 @@
           <a:p>
             <a:fld id="{F7EB0DB5-D797-4282-B608-3C30D79BDA58}" type="datetimeFigureOut">
               <a:rPr lang="hu-HU" smtClean="0"/>
-              <a:t>2026. 05. 06.</a:t>
+              <a:t>2026. 05. 09.</a:t>
             </a:fld>
             <a:endParaRPr lang="hu-HU"/>
           </a:p>
@@ -2801,7 +2803,7 @@
           <a:p>
             <a:fld id="{F7EB0DB5-D797-4282-B608-3C30D79BDA58}" type="datetimeFigureOut">
               <a:rPr lang="hu-HU" smtClean="0"/>
-              <a:t>2026. 05. 06.</a:t>
+              <a:t>2026. 05. 09.</a:t>
             </a:fld>
             <a:endParaRPr lang="hu-HU"/>
           </a:p>
@@ -2977,7 +2979,7 @@
           <a:p>
             <a:fld id="{F7EB0DB5-D797-4282-B608-3C30D79BDA58}" type="datetimeFigureOut">
               <a:rPr lang="hu-HU" smtClean="0"/>
-              <a:t>2026. 05. 06.</a:t>
+              <a:t>2026. 05. 09.</a:t>
             </a:fld>
             <a:endParaRPr lang="hu-HU"/>
           </a:p>
@@ -3224,7 +3226,7 @@
           <a:p>
             <a:fld id="{F7EB0DB5-D797-4282-B608-3C30D79BDA58}" type="datetimeFigureOut">
               <a:rPr lang="hu-HU" smtClean="0"/>
-              <a:t>2026. 05. 06.</a:t>
+              <a:t>2026. 05. 09.</a:t>
             </a:fld>
             <a:endParaRPr lang="hu-HU"/>
           </a:p>
@@ -3456,7 +3458,7 @@
           <a:p>
             <a:fld id="{F7EB0DB5-D797-4282-B608-3C30D79BDA58}" type="datetimeFigureOut">
               <a:rPr lang="hu-HU" smtClean="0"/>
-              <a:t>2026. 05. 06.</a:t>
+              <a:t>2026. 05. 09.</a:t>
             </a:fld>
             <a:endParaRPr lang="hu-HU"/>
           </a:p>
@@ -3830,7 +3832,7 @@
           <a:p>
             <a:fld id="{F7EB0DB5-D797-4282-B608-3C30D79BDA58}" type="datetimeFigureOut">
               <a:rPr lang="hu-HU" smtClean="0"/>
-              <a:t>2026. 05. 06.</a:t>
+              <a:t>2026. 05. 09.</a:t>
             </a:fld>
             <a:endParaRPr lang="hu-HU"/>
           </a:p>
@@ -3953,7 +3955,7 @@
           <a:p>
             <a:fld id="{F7EB0DB5-D797-4282-B608-3C30D79BDA58}" type="datetimeFigureOut">
               <a:rPr lang="hu-HU" smtClean="0"/>
-              <a:t>2026. 05. 06.</a:t>
+              <a:t>2026. 05. 09.</a:t>
             </a:fld>
             <a:endParaRPr lang="hu-HU"/>
           </a:p>
@@ -4048,7 +4050,7 @@
           <a:p>
             <a:fld id="{F7EB0DB5-D797-4282-B608-3C30D79BDA58}" type="datetimeFigureOut">
               <a:rPr lang="hu-HU" smtClean="0"/>
-              <a:t>2026. 05. 06.</a:t>
+              <a:t>2026. 05. 09.</a:t>
             </a:fld>
             <a:endParaRPr lang="hu-HU"/>
           </a:p>
@@ -4303,7 +4305,7 @@
           <a:p>
             <a:fld id="{F7EB0DB5-D797-4282-B608-3C30D79BDA58}" type="datetimeFigureOut">
               <a:rPr lang="hu-HU" smtClean="0"/>
-              <a:t>2026. 05. 06.</a:t>
+              <a:t>2026. 05. 09.</a:t>
             </a:fld>
             <a:endParaRPr lang="hu-HU"/>
           </a:p>
@@ -4566,7 +4568,7 @@
           <a:p>
             <a:fld id="{F7EB0DB5-D797-4282-B608-3C30D79BDA58}" type="datetimeFigureOut">
               <a:rPr lang="hu-HU" smtClean="0"/>
-              <a:t>2026. 05. 06.</a:t>
+              <a:t>2026. 05. 09.</a:t>
             </a:fld>
             <a:endParaRPr lang="hu-HU"/>
           </a:p>
@@ -5309,7 +5311,7 @@
           <a:p>
             <a:fld id="{F7EB0DB5-D797-4282-B608-3C30D79BDA58}" type="datetimeFigureOut">
               <a:rPr lang="hu-HU" smtClean="0"/>
-              <a:t>2026. 05. 06.</a:t>
+              <a:t>2026. 05. 09.</a:t>
             </a:fld>
             <a:endParaRPr lang="hu-HU"/>
           </a:p>
@@ -6310,9 +6312,34 @@
           <a:lstStyle/>
           <a:p>
             <a:r>
-              <a:rPr lang="hu-HU" dirty="0"/>
-              <a:t>Főbb metódusai</a:t>
-            </a:r>
+              <a:rPr lang="hu-HU" dirty="0" err="1"/>
+              <a:t>Throws</a:t>
+            </a:r>
+            <a:r>
+              <a:rPr lang="hu-HU" dirty="0"/>
+              <a:t> </a:t>
+            </a:r>
+            <a:r>
+              <a:rPr lang="hu-HU" dirty="0" err="1"/>
+              <a:t>exception</a:t>
+            </a:r>
+            <a:r>
+              <a:rPr lang="hu-HU" dirty="0"/>
+              <a:t> / </a:t>
+            </a:r>
+            <a:r>
+              <a:rPr lang="hu-HU" dirty="0" err="1"/>
+              <a:t>special</a:t>
+            </a:r>
+            <a:r>
+              <a:rPr lang="hu-HU" dirty="0"/>
+              <a:t> </a:t>
+            </a:r>
+            <a:r>
+              <a:rPr lang="hu-HU" dirty="0" err="1"/>
+              <a:t>value</a:t>
+            </a:r>
+            <a:endParaRPr lang="hu-HU" dirty="0"/>
           </a:p>
         </p:txBody>
       </p:sp>
@@ -6340,9 +6367,12 @@
         </p:spPr>
         <p:txBody>
           <a:bodyPr>
-            <a:normAutofit fontScale="85000" lnSpcReduction="20000"/>
+            <a:normAutofit/>
           </a:bodyPr>
           <a:lstStyle/>
+          <a:p>
+            <a:endParaRPr lang="hu-HU" dirty="0"/>
+          </a:p>
           <a:p>
             <a:r>
               <a:rPr lang="hu-HU" dirty="0" err="1"/>
@@ -6358,209 +6388,100 @@
             </a:r>
             <a:r>
               <a:rPr lang="hu-HU" dirty="0"/>
-              <a:t>:</a:t>
-            </a:r>
-            <a:br>
-              <a:rPr lang="hu-HU" dirty="0"/>
-            </a:br>
+              <a:t> (</a:t>
+            </a:r>
             <a:r>
               <a:rPr lang="hu-HU" dirty="0" err="1"/>
               <a:t>addFirst</a:t>
             </a:r>
             <a:r>
               <a:rPr lang="hu-HU" dirty="0"/>
-              <a:t>() – hozzá ad az elejéhez egy elemet(fontos, hogy dinamikus az alap implementáció, csak a memória szab határt a </a:t>
-            </a:r>
-            <a:r>
-              <a:rPr lang="hu-HU" dirty="0" err="1"/>
-              <a:t>exceptionig</a:t>
-            </a:r>
-            <a:r>
-              <a:rPr lang="hu-HU" dirty="0"/>
-              <a:t>, kivéve ha magunk implementáltunk egy maximum méretű verziót)</a:t>
-            </a:r>
-            <a:br>
-              <a:rPr lang="hu-HU" dirty="0"/>
-            </a:br>
-            <a:r>
-              <a:rPr lang="hu-HU" dirty="0" err="1"/>
-              <a:t>addLast</a:t>
-            </a:r>
-            <a:r>
-              <a:rPr lang="hu-HU" dirty="0"/>
-              <a:t>() – hozzá ad a végéhez egy elemet</a:t>
-            </a:r>
-            <a:br>
-              <a:rPr lang="hu-HU" dirty="0"/>
-            </a:br>
+              <a:t>, </a:t>
+            </a:r>
             <a:r>
               <a:rPr lang="hu-HU" dirty="0" err="1"/>
               <a:t>removeFirst</a:t>
             </a:r>
             <a:r>
               <a:rPr lang="hu-HU" dirty="0"/>
-              <a:t>() – eltávolítja a tetején lévő elemet</a:t>
-            </a:r>
-            <a:br>
-              <a:rPr lang="hu-HU" dirty="0"/>
-            </a:br>
-            <a:r>
-              <a:rPr lang="hu-HU" dirty="0" err="1"/>
-              <a:t>removeLast</a:t>
-            </a:r>
-            <a:r>
-              <a:rPr lang="hu-HU" dirty="0"/>
-              <a:t>() – eltávolítja az alján lévő elemet</a:t>
-            </a:r>
-            <a:br>
-              <a:rPr lang="hu-HU" dirty="0"/>
-            </a:br>
+              <a:t>, </a:t>
+            </a:r>
             <a:r>
               <a:rPr lang="hu-HU" dirty="0" err="1"/>
               <a:t>getFirst</a:t>
             </a:r>
             <a:r>
               <a:rPr lang="hu-HU" dirty="0"/>
-              <a:t>() – kiolvassa az első elemet</a:t>
-            </a:r>
-            <a:br>
-              <a:rPr lang="hu-HU" dirty="0"/>
-            </a:br>
+              <a:t>): ha nem sikerül (pl. üres </a:t>
+            </a:r>
             <a:r>
               <a:rPr lang="hu-HU" dirty="0" err="1"/>
-              <a:t>getLast</a:t>
-            </a:r>
-            <a:r>
-              <a:rPr lang="hu-HU" dirty="0"/>
-              <a:t>() – kiolvassa az alján lévő elemet</a:t>
-            </a:r>
-          </a:p>
-          <a:p>
-            <a:r>
-              <a:rPr lang="hu-HU" dirty="0"/>
-              <a:t>Speciális visszatérési érték – ezek nem dobnak </a:t>
+              <a:t>deque-ből</a:t>
+            </a:r>
+            <a:r>
+              <a:rPr lang="hu-HU" dirty="0"/>
+              <a:t> törlés), kivételt dob (</a:t>
             </a:r>
             <a:r>
               <a:rPr lang="hu-HU" dirty="0" err="1"/>
-              <a:t>exceptiont</a:t>
-            </a:r>
-            <a:r>
-              <a:rPr lang="hu-HU" dirty="0"/>
-              <a:t>:</a:t>
-            </a:r>
-            <a:br>
-              <a:rPr lang="hu-HU" dirty="0"/>
-            </a:br>
+              <a:t>NoSuchElementException</a:t>
+            </a:r>
+            <a:r>
+              <a:rPr lang="hu-HU" dirty="0"/>
+              <a:t>). </a:t>
+            </a:r>
+          </a:p>
+          <a:p>
+            <a:endParaRPr lang="hu-HU" dirty="0"/>
+          </a:p>
+          <a:p>
+            <a:r>
+              <a:rPr lang="hu-HU" dirty="0" err="1"/>
+              <a:t>Special</a:t>
+            </a:r>
+            <a:r>
+              <a:rPr lang="hu-HU" dirty="0"/>
+              <a:t> </a:t>
+            </a:r>
+            <a:r>
+              <a:rPr lang="hu-HU" dirty="0" err="1"/>
+              <a:t>value</a:t>
+            </a:r>
+            <a:r>
+              <a:rPr lang="hu-HU" dirty="0"/>
+              <a:t> (</a:t>
+            </a:r>
             <a:r>
               <a:rPr lang="hu-HU" dirty="0" err="1"/>
               <a:t>offerFirst</a:t>
             </a:r>
             <a:r>
               <a:rPr lang="hu-HU" dirty="0"/>
-              <a:t>() – megpróbál hozzáadni az elejéhez egy elemet</a:t>
-            </a:r>
-            <a:br>
-              <a:rPr lang="hu-HU" dirty="0"/>
-            </a:br>
-            <a:r>
-              <a:rPr lang="hu-HU" dirty="0" err="1"/>
-              <a:t>offerLast</a:t>
-            </a:r>
-            <a:r>
-              <a:rPr lang="hu-HU" dirty="0"/>
-              <a:t>() – megpróbál a végéhez hozzáadni egy elemet</a:t>
-            </a:r>
-            <a:br>
-              <a:rPr lang="hu-HU" dirty="0"/>
-            </a:br>
+              <a:t>, </a:t>
+            </a:r>
             <a:r>
               <a:rPr lang="hu-HU" dirty="0" err="1"/>
               <a:t>pollFirst</a:t>
             </a:r>
             <a:r>
               <a:rPr lang="hu-HU" dirty="0"/>
-              <a:t>() – megpróbálja eltávolítani az elején lévő elemet</a:t>
-            </a:r>
-            <a:br>
-              <a:rPr lang="hu-HU" dirty="0"/>
-            </a:br>
-            <a:r>
-              <a:rPr lang="hu-HU" dirty="0" err="1"/>
-              <a:t>pollLast</a:t>
-            </a:r>
-            <a:r>
-              <a:rPr lang="hu-HU" dirty="0"/>
-              <a:t>() – megpróbálja eltávolítani az alján lévő elemet</a:t>
-            </a:r>
-            <a:br>
-              <a:rPr lang="hu-HU" dirty="0"/>
-            </a:br>
+              <a:t>, </a:t>
+            </a:r>
             <a:r>
               <a:rPr lang="hu-HU" dirty="0" err="1"/>
               <a:t>peekFirst</a:t>
             </a:r>
             <a:r>
               <a:rPr lang="hu-HU" dirty="0"/>
-              <a:t>() – megpróbálja kiolvasni az első elemet</a:t>
-            </a:r>
-            <a:br>
-              <a:rPr lang="hu-HU" dirty="0"/>
-            </a:br>
+              <a:t>): ha nem sikerül, null-t vagy </a:t>
+            </a:r>
             <a:r>
               <a:rPr lang="hu-HU" dirty="0" err="1"/>
-              <a:t>peekLast</a:t>
-            </a:r>
-            <a:r>
-              <a:rPr lang="hu-HU" dirty="0"/>
-              <a:t>() – megpróbálja kiolvasni az alján lévő elemet</a:t>
-            </a:r>
-          </a:p>
-          <a:p>
-            <a:endParaRPr lang="hu-HU" dirty="0"/>
-          </a:p>
-          <a:p>
-            <a:r>
-              <a:rPr lang="hu-HU" dirty="0"/>
-              <a:t>A </a:t>
-            </a:r>
-            <a:r>
-              <a:rPr lang="hu-HU" dirty="0" err="1"/>
-              <a:t>remove</a:t>
-            </a:r>
-            <a:r>
-              <a:rPr lang="hu-HU" dirty="0"/>
-              <a:t>/</a:t>
-            </a:r>
-            <a:r>
-              <a:rPr lang="hu-HU" dirty="0" err="1"/>
-              <a:t>poll</a:t>
-            </a:r>
-            <a:r>
-              <a:rPr lang="hu-HU" dirty="0"/>
-              <a:t> – </a:t>
-            </a:r>
-            <a:r>
-              <a:rPr lang="hu-HU" dirty="0" err="1"/>
-              <a:t>get</a:t>
-            </a:r>
-            <a:r>
-              <a:rPr lang="hu-HU" dirty="0"/>
-              <a:t>/</a:t>
-            </a:r>
-            <a:r>
-              <a:rPr lang="hu-HU" dirty="0" err="1"/>
-              <a:t>peek</a:t>
-            </a:r>
-            <a:r>
-              <a:rPr lang="hu-HU" dirty="0"/>
-              <a:t> között az a különbség, hogy az előbbi eltávolítja az elemet,</a:t>
-            </a:r>
-            <a:br>
-              <a:rPr lang="hu-HU" dirty="0"/>
-            </a:br>
-            <a:r>
-              <a:rPr lang="hu-HU" dirty="0"/>
-              <a:t>az utóbbi csak megnézi, vissza adja az adott elemet</a:t>
+              <a:t>false</a:t>
+            </a:r>
+            <a:r>
+              <a:rPr lang="hu-HU" dirty="0"/>
+              <a:t>-t ad vissza, nem dob kivételt.</a:t>
             </a:r>
           </a:p>
           <a:p>
@@ -6572,6 +6493,500 @@
     <p:extLst>
       <p:ext uri="{BB962C8B-B14F-4D97-AF65-F5344CB8AC3E}">
         <p14:creationId xmlns:p14="http://schemas.microsoft.com/office/powerpoint/2010/main" val="4205760558"/>
+      </p:ext>
+    </p:extLst>
+  </p:cSld>
+  <p:clrMapOvr>
+    <a:masterClrMapping/>
+  </p:clrMapOvr>
+</p:sld>
+</file>
+
+<file path=ppt/slides/slide6.xml><?xml version="1.0" encoding="utf-8"?>
+<p:sld xmlns:a="http://schemas.openxmlformats.org/drawingml/2006/main" xmlns:r="http://schemas.openxmlformats.org/officeDocument/2006/relationships" xmlns:p="http://schemas.openxmlformats.org/presentationml/2006/main">
+  <p:cSld>
+    <p:spTree>
+      <p:nvGrpSpPr>
+        <p:cNvPr id="1" name=""/>
+        <p:cNvGrpSpPr/>
+        <p:nvPr/>
+      </p:nvGrpSpPr>
+      <p:grpSpPr>
+        <a:xfrm>
+          <a:off x="0" y="0"/>
+          <a:ext cx="0" cy="0"/>
+          <a:chOff x="0" y="0"/>
+          <a:chExt cx="0" cy="0"/>
+        </a:xfrm>
+      </p:grpSpPr>
+      <p:sp>
+        <p:nvSpPr>
+          <p:cNvPr id="2" name="Cím 1">
+            <a:extLst>
+              <a:ext uri="{FF2B5EF4-FFF2-40B4-BE49-F238E27FC236}">
+                <a16:creationId xmlns:a16="http://schemas.microsoft.com/office/drawing/2014/main" id="{312C1631-BEF3-8E7F-B533-4E8C245528F5}"/>
+              </a:ext>
+            </a:extLst>
+          </p:cNvPr>
+          <p:cNvSpPr>
+            <a:spLocks noGrp="1"/>
+          </p:cNvSpPr>
+          <p:nvPr>
+            <p:ph type="title"/>
+          </p:nvPr>
+        </p:nvSpPr>
+        <p:spPr/>
+        <p:txBody>
+          <a:bodyPr/>
+          <a:lstStyle/>
+          <a:p>
+            <a:r>
+              <a:rPr lang="hu-HU" dirty="0"/>
+              <a:t>Főbb metódusai</a:t>
+            </a:r>
+          </a:p>
+        </p:txBody>
+      </p:sp>
+      <p:sp>
+        <p:nvSpPr>
+          <p:cNvPr id="3" name="Tartalom helye 2">
+            <a:extLst>
+              <a:ext uri="{FF2B5EF4-FFF2-40B4-BE49-F238E27FC236}">
+                <a16:creationId xmlns:a16="http://schemas.microsoft.com/office/drawing/2014/main" id="{8C169285-EF1D-764F-DA5A-D5907A034DF8}"/>
+              </a:ext>
+            </a:extLst>
+          </p:cNvPr>
+          <p:cNvSpPr>
+            <a:spLocks noGrp="1"/>
+          </p:cNvSpPr>
+          <p:nvPr>
+            <p:ph idx="1"/>
+          </p:nvPr>
+        </p:nvSpPr>
+        <p:spPr>
+          <a:xfrm>
+            <a:off x="677334" y="2160589"/>
+            <a:ext cx="8596668" cy="4240211"/>
+          </a:xfrm>
+        </p:spPr>
+        <p:txBody>
+          <a:bodyPr>
+            <a:normAutofit fontScale="85000" lnSpcReduction="20000"/>
+          </a:bodyPr>
+          <a:lstStyle/>
+          <a:p>
+            <a:r>
+              <a:rPr lang="hu-HU" dirty="0" err="1"/>
+              <a:t>Throws</a:t>
+            </a:r>
+            <a:r>
+              <a:rPr lang="hu-HU" dirty="0"/>
+              <a:t> </a:t>
+            </a:r>
+            <a:r>
+              <a:rPr lang="hu-HU" dirty="0" err="1"/>
+              <a:t>exception</a:t>
+            </a:r>
+            <a:r>
+              <a:rPr lang="hu-HU" dirty="0"/>
+              <a:t>:</a:t>
+            </a:r>
+            <a:br>
+              <a:rPr lang="hu-HU" dirty="0"/>
+            </a:br>
+            <a:r>
+              <a:rPr lang="hu-HU" dirty="0" err="1"/>
+              <a:t>addFirst</a:t>
+            </a:r>
+            <a:r>
+              <a:rPr lang="hu-HU" dirty="0"/>
+              <a:t>() – hozzá ad az elejéhez egy elemet(fontos, hogy dinamikus az alap implementáció, csak a memória szab határt a </a:t>
+            </a:r>
+            <a:r>
+              <a:rPr lang="hu-HU" dirty="0" err="1"/>
+              <a:t>exceptionig</a:t>
+            </a:r>
+            <a:r>
+              <a:rPr lang="hu-HU" dirty="0"/>
+              <a:t>, kivéve ha magunk implementáltunk egy maximum méretű verziót)</a:t>
+            </a:r>
+            <a:br>
+              <a:rPr lang="hu-HU" dirty="0"/>
+            </a:br>
+            <a:r>
+              <a:rPr lang="hu-HU" dirty="0" err="1"/>
+              <a:t>addLast</a:t>
+            </a:r>
+            <a:r>
+              <a:rPr lang="hu-HU" dirty="0"/>
+              <a:t>() – hozzá ad a végéhez egy elemet</a:t>
+            </a:r>
+            <a:br>
+              <a:rPr lang="hu-HU" dirty="0"/>
+            </a:br>
+            <a:r>
+              <a:rPr lang="hu-HU" dirty="0" err="1"/>
+              <a:t>removeFirst</a:t>
+            </a:r>
+            <a:r>
+              <a:rPr lang="hu-HU" dirty="0"/>
+              <a:t>() – eltávolítja a tetején lévő elemet</a:t>
+            </a:r>
+            <a:br>
+              <a:rPr lang="hu-HU" dirty="0"/>
+            </a:br>
+            <a:r>
+              <a:rPr lang="hu-HU" dirty="0" err="1"/>
+              <a:t>removeLast</a:t>
+            </a:r>
+            <a:r>
+              <a:rPr lang="hu-HU" dirty="0"/>
+              <a:t>() – eltávolítja az alján lévő elemet</a:t>
+            </a:r>
+            <a:br>
+              <a:rPr lang="hu-HU" dirty="0"/>
+            </a:br>
+            <a:r>
+              <a:rPr lang="hu-HU" dirty="0" err="1"/>
+              <a:t>getFirst</a:t>
+            </a:r>
+            <a:r>
+              <a:rPr lang="hu-HU" dirty="0"/>
+              <a:t>() – kiolvassa az első elemet</a:t>
+            </a:r>
+            <a:br>
+              <a:rPr lang="hu-HU" dirty="0"/>
+            </a:br>
+            <a:r>
+              <a:rPr lang="hu-HU" dirty="0" err="1"/>
+              <a:t>getLast</a:t>
+            </a:r>
+            <a:r>
+              <a:rPr lang="hu-HU" dirty="0"/>
+              <a:t>() – kiolvassa az alján lévő elemet</a:t>
+            </a:r>
+          </a:p>
+          <a:p>
+            <a:r>
+              <a:rPr lang="hu-HU" dirty="0"/>
+              <a:t>Speciális visszatérési érték – ezek nem dobnak </a:t>
+            </a:r>
+            <a:r>
+              <a:rPr lang="hu-HU" dirty="0" err="1"/>
+              <a:t>exceptiont</a:t>
+            </a:r>
+            <a:r>
+              <a:rPr lang="hu-HU" dirty="0"/>
+              <a:t>:</a:t>
+            </a:r>
+            <a:br>
+              <a:rPr lang="hu-HU" dirty="0"/>
+            </a:br>
+            <a:r>
+              <a:rPr lang="hu-HU" dirty="0" err="1"/>
+              <a:t>offerFirst</a:t>
+            </a:r>
+            <a:r>
+              <a:rPr lang="hu-HU" dirty="0"/>
+              <a:t>() – megpróbál hozzáadni az elejéhez egy elemet</a:t>
+            </a:r>
+            <a:br>
+              <a:rPr lang="hu-HU" dirty="0"/>
+            </a:br>
+            <a:r>
+              <a:rPr lang="hu-HU" dirty="0" err="1"/>
+              <a:t>offerLast</a:t>
+            </a:r>
+            <a:r>
+              <a:rPr lang="hu-HU" dirty="0"/>
+              <a:t>() – megpróbál a végéhez hozzáadni egy elemet</a:t>
+            </a:r>
+            <a:br>
+              <a:rPr lang="hu-HU" dirty="0"/>
+            </a:br>
+            <a:r>
+              <a:rPr lang="hu-HU" dirty="0" err="1"/>
+              <a:t>pollFirst</a:t>
+            </a:r>
+            <a:r>
+              <a:rPr lang="hu-HU" dirty="0"/>
+              <a:t>() – megpróbálja eltávolítani az elején lévő elemet</a:t>
+            </a:r>
+            <a:br>
+              <a:rPr lang="hu-HU" dirty="0"/>
+            </a:br>
+            <a:r>
+              <a:rPr lang="hu-HU" dirty="0" err="1"/>
+              <a:t>pollLast</a:t>
+            </a:r>
+            <a:r>
+              <a:rPr lang="hu-HU" dirty="0"/>
+              <a:t>() – megpróbálja eltávolítani az alján lévő elemet</a:t>
+            </a:r>
+            <a:br>
+              <a:rPr lang="hu-HU" dirty="0"/>
+            </a:br>
+            <a:r>
+              <a:rPr lang="hu-HU" dirty="0" err="1"/>
+              <a:t>peekFirst</a:t>
+            </a:r>
+            <a:r>
+              <a:rPr lang="hu-HU" dirty="0"/>
+              <a:t>() – megpróbálja kiolvasni az első elemet</a:t>
+            </a:r>
+            <a:br>
+              <a:rPr lang="hu-HU" dirty="0"/>
+            </a:br>
+            <a:r>
+              <a:rPr lang="hu-HU" dirty="0" err="1"/>
+              <a:t>peekLast</a:t>
+            </a:r>
+            <a:r>
+              <a:rPr lang="hu-HU" dirty="0"/>
+              <a:t>() – megpróbálja kiolvasni az alján lévő elemet</a:t>
+            </a:r>
+          </a:p>
+          <a:p>
+            <a:endParaRPr lang="hu-HU" dirty="0"/>
+          </a:p>
+          <a:p>
+            <a:r>
+              <a:rPr lang="hu-HU" dirty="0"/>
+              <a:t>A </a:t>
+            </a:r>
+            <a:r>
+              <a:rPr lang="hu-HU" dirty="0" err="1"/>
+              <a:t>remove</a:t>
+            </a:r>
+            <a:r>
+              <a:rPr lang="hu-HU" dirty="0"/>
+              <a:t>/</a:t>
+            </a:r>
+            <a:r>
+              <a:rPr lang="hu-HU" dirty="0" err="1"/>
+              <a:t>poll</a:t>
+            </a:r>
+            <a:r>
+              <a:rPr lang="hu-HU" dirty="0"/>
+              <a:t> – </a:t>
+            </a:r>
+            <a:r>
+              <a:rPr lang="hu-HU" dirty="0" err="1"/>
+              <a:t>get</a:t>
+            </a:r>
+            <a:r>
+              <a:rPr lang="hu-HU" dirty="0"/>
+              <a:t>/</a:t>
+            </a:r>
+            <a:r>
+              <a:rPr lang="hu-HU" dirty="0" err="1"/>
+              <a:t>peek</a:t>
+            </a:r>
+            <a:r>
+              <a:rPr lang="hu-HU" dirty="0"/>
+              <a:t> között az a különbség, hogy az előbbi eltávolítja az elemet,</a:t>
+            </a:r>
+            <a:br>
+              <a:rPr lang="hu-HU" dirty="0"/>
+            </a:br>
+            <a:r>
+              <a:rPr lang="hu-HU" dirty="0"/>
+              <a:t>az utóbbi csak megnézi, vissza adja az adott elemet</a:t>
+            </a:r>
+          </a:p>
+          <a:p>
+            <a:endParaRPr lang="hu-HU" dirty="0"/>
+          </a:p>
+        </p:txBody>
+      </p:sp>
+    </p:spTree>
+    <p:extLst>
+      <p:ext uri="{BB962C8B-B14F-4D97-AF65-F5344CB8AC3E}">
+        <p14:creationId xmlns:p14="http://schemas.microsoft.com/office/powerpoint/2010/main" val="1167365235"/>
+      </p:ext>
+    </p:extLst>
+  </p:cSld>
+  <p:clrMapOvr>
+    <a:masterClrMapping/>
+  </p:clrMapOvr>
+</p:sld>
+</file>
+
+<file path=ppt/slides/slide7.xml><?xml version="1.0" encoding="utf-8"?>
+<p:sld xmlns:a="http://schemas.openxmlformats.org/drawingml/2006/main" xmlns:r="http://schemas.openxmlformats.org/officeDocument/2006/relationships" xmlns:p="http://schemas.openxmlformats.org/presentationml/2006/main">
+  <p:cSld>
+    <p:spTree>
+      <p:nvGrpSpPr>
+        <p:cNvPr id="1" name=""/>
+        <p:cNvGrpSpPr/>
+        <p:nvPr/>
+      </p:nvGrpSpPr>
+      <p:grpSpPr>
+        <a:xfrm>
+          <a:off x="0" y="0"/>
+          <a:ext cx="0" cy="0"/>
+          <a:chOff x="0" y="0"/>
+          <a:chExt cx="0" cy="0"/>
+        </a:xfrm>
+      </p:grpSpPr>
+      <p:sp>
+        <p:nvSpPr>
+          <p:cNvPr id="2" name="Cím 1">
+            <a:extLst>
+              <a:ext uri="{FF2B5EF4-FFF2-40B4-BE49-F238E27FC236}">
+                <a16:creationId xmlns:a16="http://schemas.microsoft.com/office/drawing/2014/main" id="{312C1631-BEF3-8E7F-B533-4E8C245528F5}"/>
+              </a:ext>
+            </a:extLst>
+          </p:cNvPr>
+          <p:cNvSpPr>
+            <a:spLocks noGrp="1"/>
+          </p:cNvSpPr>
+          <p:nvPr>
+            <p:ph type="title"/>
+          </p:nvPr>
+        </p:nvSpPr>
+        <p:spPr/>
+        <p:txBody>
+          <a:bodyPr/>
+          <a:lstStyle/>
+          <a:p>
+            <a:r>
+              <a:rPr lang="hu-HU" dirty="0" err="1"/>
+              <a:t>ArrayDeque</a:t>
+            </a:r>
+            <a:r>
+              <a:rPr lang="hu-HU" dirty="0"/>
+              <a:t> </a:t>
+            </a:r>
+            <a:r>
+              <a:rPr lang="hu-HU" dirty="0" err="1"/>
+              <a:t>vs</a:t>
+            </a:r>
+            <a:r>
+              <a:rPr lang="hu-HU" dirty="0"/>
+              <a:t> </a:t>
+            </a:r>
+            <a:r>
+              <a:rPr lang="hu-HU" dirty="0" err="1"/>
+              <a:t>LinkedList</a:t>
+            </a:r>
+            <a:endParaRPr lang="hu-HU" dirty="0"/>
+          </a:p>
+        </p:txBody>
+      </p:sp>
+      <p:sp>
+        <p:nvSpPr>
+          <p:cNvPr id="3" name="Tartalom helye 2">
+            <a:extLst>
+              <a:ext uri="{FF2B5EF4-FFF2-40B4-BE49-F238E27FC236}">
+                <a16:creationId xmlns:a16="http://schemas.microsoft.com/office/drawing/2014/main" id="{8C169285-EF1D-764F-DA5A-D5907A034DF8}"/>
+              </a:ext>
+            </a:extLst>
+          </p:cNvPr>
+          <p:cNvSpPr>
+            <a:spLocks noGrp="1"/>
+          </p:cNvSpPr>
+          <p:nvPr>
+            <p:ph idx="1"/>
+          </p:nvPr>
+        </p:nvSpPr>
+        <p:spPr>
+          <a:xfrm>
+            <a:off x="677334" y="2160589"/>
+            <a:ext cx="8596668" cy="4240211"/>
+          </a:xfrm>
+        </p:spPr>
+        <p:txBody>
+          <a:bodyPr>
+            <a:normAutofit/>
+          </a:bodyPr>
+          <a:lstStyle/>
+          <a:p>
+            <a:r>
+              <a:rPr lang="hu-HU" dirty="0"/>
+              <a:t>Az </a:t>
+            </a:r>
+            <a:r>
+              <a:rPr lang="hu-HU" dirty="0" err="1"/>
+              <a:t>ArrayDeque</a:t>
+            </a:r>
+            <a:r>
+              <a:rPr lang="hu-HU" dirty="0"/>
+              <a:t> belül egy körkörös (</a:t>
+            </a:r>
+            <a:r>
+              <a:rPr lang="hu-HU" dirty="0" err="1"/>
+              <a:t>circular</a:t>
+            </a:r>
+            <a:r>
+              <a:rPr lang="hu-HU" dirty="0"/>
+              <a:t>) tömböt használ. Két pointer (</a:t>
+            </a:r>
+            <a:r>
+              <a:rPr lang="hu-HU" dirty="0" err="1"/>
+              <a:t>head</a:t>
+            </a:r>
+            <a:r>
+              <a:rPr lang="hu-HU" dirty="0"/>
+              <a:t> és </a:t>
+            </a:r>
+            <a:r>
+              <a:rPr lang="hu-HU" dirty="0" err="1"/>
+              <a:t>tail</a:t>
+            </a:r>
+            <a:r>
+              <a:rPr lang="hu-HU" dirty="0"/>
+              <a:t>) mutatja, hol van az eleje és a vége. Ha valamelyik pointer eléri a tömb végét, visszaugrik az elejére (</a:t>
+            </a:r>
+            <a:r>
+              <a:rPr lang="hu-HU" dirty="0" err="1"/>
+              <a:t>modulo</a:t>
+            </a:r>
+            <a:r>
+              <a:rPr lang="hu-HU" dirty="0"/>
+              <a:t> aritmetika).</a:t>
+            </a:r>
+          </a:p>
+          <a:p>
+            <a:endParaRPr lang="hu-HU" dirty="0"/>
+          </a:p>
+          <a:p>
+            <a:r>
+              <a:rPr lang="hu-HU" dirty="0"/>
+              <a:t>Ha a tömb megtelik, automatikusan dupláz (új, kétszer akkora tömböt hoz létre és átmásolja az elemeket).</a:t>
+            </a:r>
+          </a:p>
+          <a:p>
+            <a:endParaRPr lang="hu-HU" dirty="0"/>
+          </a:p>
+          <a:p>
+            <a:r>
+              <a:rPr lang="hu-HU" dirty="0"/>
+              <a:t>Ezért gyorsabb, mint a </a:t>
+            </a:r>
+            <a:r>
+              <a:rPr lang="hu-HU" dirty="0" err="1"/>
+              <a:t>LinkedList</a:t>
+            </a:r>
+            <a:r>
+              <a:rPr lang="hu-HU" dirty="0"/>
+              <a:t> — nincs </a:t>
+            </a:r>
+            <a:r>
+              <a:rPr lang="hu-HU" dirty="0" err="1"/>
+              <a:t>node</a:t>
+            </a:r>
+            <a:r>
+              <a:rPr lang="hu-HU" dirty="0"/>
+              <a:t>-ok közötti pointeres ugrálás, a memóriában egymás mellett vannak az elemek (cache-barát).</a:t>
+            </a:r>
+          </a:p>
+        </p:txBody>
+      </p:sp>
+    </p:spTree>
+    <p:extLst>
+      <p:ext uri="{BB962C8B-B14F-4D97-AF65-F5344CB8AC3E}">
+        <p14:creationId xmlns:p14="http://schemas.microsoft.com/office/powerpoint/2010/main" val="2335949521"/>
       </p:ext>
     </p:extLst>
   </p:cSld>

</xml_diff>